<commit_message>
docs: fix slide 7's AI-failure claim, note timer escalation on slide 9
</commit_message>
<xml_diff>
--- a/docs/Triage_Guard_Presentation.pptx
+++ b/docs/Triage_Guard_Presentation.pptx
@@ -29363,7 +29363,7 @@
                 <a:cs typeface="Arial"/>
                 <a:sym typeface="Arial"/>
               </a:rPr>
-              <a:t>כשה-AI מציע משהו אסור</a:t>
+              <a:t>כשה-AI מחזיר תשובה לא תקינה</a:t>
             </a:r>
             <a:endParaRPr b="0" i="0" sz="1900" u="none" cap="none" strike="noStrike">
               <a:solidFill>
@@ -29426,7 +29426,7 @@
                 <a:cs typeface="Arial"/>
                 <a:sym typeface="Arial"/>
               </a:rPr>
-              <a:t>הפעולה לא מתבצעת. היא נחסמת, נרשמת ביומן עם השכבה שחסמה (OPA או Prolog) וההסבר שלה.</a:t>
+              <a:t>תשובה שלא בפורמט או מחוץ לטווח 5 עד 1 נזרקת, וה-AI נשאל שוב. אחרי שני כישלונות ממשיכים עם הרמה של האחות, והמקרה מסומן. רמה שסותרת את הרשומה נתפסת בבדיקת הבטיחות (Prolog) ועוברת לאחות אחראית.</a:t>
             </a:r>
             <a:endParaRPr b="0" i="0" sz="1950" u="none" cap="none" strike="noStrike">
               <a:solidFill>
@@ -34286,7 +34286,7 @@
                 <a:cs typeface="Arial"/>
                 <a:sym typeface="Arial"/>
               </a:rPr>
-              <a:t>טיימר שלא ברור אם פעל נבדק קודם ביומן, ואחרי 3 ניסיונות אדם מקבל התראה. לכל היותר 5 התראות בשעה לכל קבוצת נמענים.</a:t>
+              <a:t>טיימר שלא ברור אם פעל נבדק קודם ביומן, ואחרי 3 ניסיונות אדם מקבל התראה. טיימר שנכשל 3 פעמים ברצף מוסלם לטכנאי. לכל היותר 5 התראות בשעה לכל קבוצת נמענים.</a:t>
             </a:r>
             <a:endParaRPr b="0" i="0" sz="1750" u="none" cap="none" strike="noStrike">
               <a:solidFill>

</xml_diff>

<commit_message>
feat: safety and gate fixes, AI reasoning at the gate, richer visit history
- dead RETRY/EXHAUSTED safety edges removed (validator-down path still drawn)
- board validator-down options restored
- safety rule 5 judged per triage
- retry budgets reset on re-file
- classifier asked again on a malformed answer
- AI reasoning and confidence shown, collapsed, at the gate
- past visits keep complaint and vitals for the model
- slides 7 and 9 corrected
</commit_message>
<xml_diff>
--- a/docs/Triage_Guard_Presentation.pptx
+++ b/docs/Triage_Guard_Presentation.pptx
@@ -29363,7 +29363,7 @@
                 <a:cs typeface="Arial"/>
                 <a:sym typeface="Arial"/>
               </a:rPr>
-              <a:t>כשה-AI מציע משהו אסור</a:t>
+              <a:t>כשה-AI מחזיר תשובה לא תקינה</a:t>
             </a:r>
             <a:endParaRPr b="0" i="0" sz="1900" u="none" cap="none" strike="noStrike">
               <a:solidFill>
@@ -29426,7 +29426,7 @@
                 <a:cs typeface="Arial"/>
                 <a:sym typeface="Arial"/>
               </a:rPr>
-              <a:t>הפעולה לא מתבצעת. היא נחסמת, נרשמת ביומן עם השכבה שחסמה (OPA או Prolog) וההסבר שלה.</a:t>
+              <a:t>תשובה שלא בפורמט או מחוץ לטווח 5 עד 1 נזרקת, וה-AI נשאל שוב. אחרי שני כישלונות ממשיכים עם הרמה של האחות, והמקרה מסומן. רמה שסותרת את הרשומה נתפסת בבדיקת הבטיחות (Prolog) ועוברת לאחות אחראית.</a:t>
             </a:r>
             <a:endParaRPr b="0" i="0" sz="1950" u="none" cap="none" strike="noStrike">
               <a:solidFill>
@@ -34286,7 +34286,7 @@
                 <a:cs typeface="Arial"/>
                 <a:sym typeface="Arial"/>
               </a:rPr>
-              <a:t>טיימר שלא ברור אם פעל נבדק קודם ביומן, ואחרי 3 ניסיונות אדם מקבל התראה. לכל היותר 5 התראות בשעה לכל קבוצת נמענים.</a:t>
+              <a:t>טיימר שלא ברור אם פעל נבדק קודם ביומן, ואחרי 3 ניסיונות אדם מקבל התראה. טיימר שנכשל 3 פעמים ברצף מוסלם לטכנאי. לכל היותר 5 התראות בשעה לכל קבוצת נמענים.</a:t>
             </a:r>
             <a:endParaRPr b="0" i="0" sz="1750" u="none" cap="none" strike="noStrike">
               <a:solidFill>

</xml_diff>

<commit_message>
docs(slides): OPA move rule shows order_settled, privacy refusal on slide 11, test count
- Slide 8: the OPA move excerpt now includes order_settled, matching
  monitor.rego (an out-of-order move needs a reason from the fixed list).
- Slide 11: says what a privacy refusal does: the data is not sent to the
  AI, the nurse's level is used, the technician is alerted.
- Slide 10: 1,000+ automated tests (821 triage-app, 168 board, 24 crm-stub).
</commit_message>
<xml_diff>
--- a/docs/Triage_Guard_Presentation.pptx
+++ b/docs/Triage_Guard_Presentation.pptx
@@ -5419,7 +5419,7 @@
                 <a:cs typeface="Arial"/>
                 <a:sym typeface="Arial"/>
               </a:rPr>
-              <a:t>500+</a:t>
+              <a:t>1,000+</a:t>
             </a:r>
             <a:endParaRPr b="0" i="0" sz="5000" u="none" cap="none" strike="noStrike">
               <a:solidFill>
@@ -8058,7 +8058,7 @@
                           <a:cs typeface="Arial"/>
                           <a:sym typeface="Arial"/>
                         </a:rPr>
-                        <a:t>רק רשימה מאושרת של שדות מגיעה ל-AI, ו-OPA בודק אותה. פרט מזהה שהוקלד מוחלף בסימון [REDACTED] לפני ה-AI ובכל מה שנשלח ל-Langfuse. המקרה עצמו שומר רק מזהה פנימי, והפרטים המזהים נשמרים רק במערכת הרשומות של בית החולים (CRM).</a:t>
+                        <a:t>רק רשימה מאושרת של שדות מגיעה ל-AI, ו-OPA בודק אותה. אם OPA דוחה אותה, היא לא נשלחת ל-AI: ממשיכים עם הרמה של האחות, והטכנאי מקבל התראה. פרט מזהה שהוקלד מוחלף בסימון [REDACTED] לפני ה-AI ובכל מה שנשלח ל-Langfuse. המקרה עצמו שומר רק מזהה פנימי, והפרטים המזהים נשמרים רק במערכת הרשומות של בית החולים (CRM).</a:t>
                       </a:r>
                       <a:endParaRPr sz="1850" u="none" cap="none" strike="noStrike">
                         <a:latin typeface="Arial"/>
@@ -30050,12 +30050,12 @@
               <a:buClr>
                 <a:srgbClr val="C9C6F5"/>
               </a:buClr>
-              <a:buSzPts val="1350"/>
+              <a:buSzPts val="1200"/>
               <a:buFont typeface="Courier New"/>
               <a:buNone/>
             </a:pPr>
             <a:r>
-              <a:rPr b="0" i="0" lang="iw-IL" sz="1350" u="none" cap="none" strike="noStrike">
+              <a:rPr b="0" i="0" lang="iw-IL" sz="1200" u="none" cap="none" strike="noStrike">
                 <a:solidFill>
                   <a:srgbClr val="C9C6F5"/>
                 </a:solidFill>
@@ -30066,7 +30066,7 @@
               </a:rPr>
               <a:t>allow if {</a:t>
             </a:r>
-            <a:endParaRPr b="0" i="0" sz="1350" u="none" cap="none" strike="noStrike">
+            <a:endParaRPr b="0" i="0" sz="1200" u="none" cap="none" strike="noStrike">
               <a:solidFill>
                 <a:schemeClr val="dk1"/>
               </a:solidFill>
@@ -30087,12 +30087,12 @@
               <a:buClr>
                 <a:srgbClr val="C9C6F5"/>
               </a:buClr>
-              <a:buSzPts val="1350"/>
+              <a:buSzPts val="1200"/>
               <a:buFont typeface="Courier New"/>
               <a:buNone/>
             </a:pPr>
             <a:r>
-              <a:rPr b="0" i="0" lang="iw-IL" sz="1350" u="none" cap="none" strike="noStrike">
+              <a:rPr b="0" i="0" lang="iw-IL" sz="1200" u="none" cap="none" strike="noStrike">
                 <a:solidFill>
                   <a:srgbClr val="C9C6F5"/>
                 </a:solidFill>
@@ -30103,7 +30103,7 @@
               </a:rPr>
               <a:t>  input.action == "move"</a:t>
             </a:r>
-            <a:endParaRPr b="0" i="0" sz="1350" u="none" cap="none" strike="noStrike">
+            <a:endParaRPr b="0" i="0" sz="1200" u="none" cap="none" strike="noStrike">
               <a:solidFill>
                 <a:schemeClr val="dk1"/>
               </a:solidFill>
@@ -30124,12 +30124,12 @@
               <a:buClr>
                 <a:srgbClr val="C9C6F5"/>
               </a:buClr>
-              <a:buSzPts val="1350"/>
+              <a:buSzPts val="1200"/>
               <a:buFont typeface="Courier New"/>
               <a:buNone/>
             </a:pPr>
             <a:r>
-              <a:rPr b="0" i="0" lang="iw-IL" sz="1350" u="none" cap="none" strike="noStrike">
+              <a:rPr b="0" i="0" lang="iw-IL" sz="1200" u="none" cap="none" strike="noStrike">
                 <a:solidFill>
                   <a:srgbClr val="C9C6F5"/>
                 </a:solidFill>
@@ -30140,7 +30140,7 @@
               </a:rPr>
               <a:t>  safety_settled</a:t>
             </a:r>
-            <a:endParaRPr b="0" i="0" sz="1350" u="none" cap="none" strike="noStrike">
+            <a:endParaRPr b="0" i="0" sz="1200" u="none" cap="none" strike="noStrike">
               <a:solidFill>
                 <a:schemeClr val="dk1"/>
               </a:solidFill>
@@ -30161,12 +30161,12 @@
               <a:buClr>
                 <a:srgbClr val="C9C6F5"/>
               </a:buClr>
-              <a:buSzPts val="1350"/>
+              <a:buSzPts val="1200"/>
               <a:buFont typeface="Courier New"/>
               <a:buNone/>
             </a:pPr>
             <a:r>
-              <a:rPr b="0" i="0" lang="iw-IL" sz="1350" u="none" cap="none" strike="noStrike">
+              <a:rPr b="0" i="0" lang="iw-IL" sz="1200" u="none" cap="none" strike="noStrike">
                 <a:solidFill>
                   <a:srgbClr val="C9C6F5"/>
                 </a:solidFill>
@@ -30177,7 +30177,7 @@
               </a:rPr>
               <a:t>  input.case.approved == true</a:t>
             </a:r>
-            <a:endParaRPr b="0" i="0" sz="1350" u="none" cap="none" strike="noStrike">
+            <a:endParaRPr b="0" i="0" sz="1200" u="none" cap="none" strike="noStrike">
               <a:solidFill>
                 <a:schemeClr val="dk1"/>
               </a:solidFill>
@@ -30198,12 +30198,12 @@
               <a:buClr>
                 <a:srgbClr val="C9C6F5"/>
               </a:buClr>
-              <a:buSzPts val="1350"/>
+              <a:buSzPts val="1200"/>
               <a:buFont typeface="Courier New"/>
               <a:buNone/>
             </a:pPr>
             <a:r>
-              <a:rPr b="0" i="0" lang="iw-IL" sz="1350" u="none" cap="none" strike="noStrike">
+              <a:rPr b="0" i="0" lang="iw-IL" sz="1200" u="none" cap="none" strike="noStrike">
                 <a:solidFill>
                   <a:srgbClr val="C9C6F5"/>
                 </a:solidFill>
@@ -30214,7 +30214,7 @@
               </a:rPr>
               <a:t>  input.actor_role in move_roles</a:t>
             </a:r>
-            <a:endParaRPr b="0" i="0" sz="1350" u="none" cap="none" strike="noStrike">
+            <a:endParaRPr b="0" i="0" sz="1200" u="none" cap="none" strike="noStrike">
               <a:solidFill>
                 <a:schemeClr val="dk1"/>
               </a:solidFill>
@@ -30235,12 +30235,49 @@
               <a:buClr>
                 <a:srgbClr val="C9C6F5"/>
               </a:buClr>
-              <a:buSzPts val="1350"/>
+              <a:buSzPts val="1200"/>
               <a:buFont typeface="Courier New"/>
               <a:buNone/>
             </a:pPr>
             <a:r>
-              <a:rPr b="0" i="0" lang="iw-IL" sz="1350" u="none" cap="none" strike="noStrike">
+              <a:rPr b="0" i="0" lang="iw-IL" sz="1200" u="none" cap="none" strike="noStrike">
+                <a:solidFill>
+                  <a:srgbClr val="C9C6F5"/>
+                </a:solidFill>
+                <a:latin typeface="Courier New"/>
+                <a:ea typeface="Courier New"/>
+                <a:cs typeface="Courier New"/>
+                <a:sym typeface="Courier New"/>
+              </a:rPr>
+              <a:t>  order_settled</a:t>
+            </a:r>
+            <a:endParaRPr b="0" i="0" sz="1200" u="none" cap="none" strike="noStrike">
+              <a:solidFill>
+                <a:schemeClr val="dk1"/>
+              </a:solidFill>
+              <a:latin typeface="Calibri"/>
+              <a:ea typeface="Calibri"/>
+              <a:cs typeface="Calibri"/>
+              <a:sym typeface="Calibri"/>
+            </a:endParaRPr>
+          </a:p>
+          <a:p>
+            <a:pPr indent="0" lvl="0" marL="0" marR="0" rtl="0" algn="l">
+              <a:spcBef>
+                <a:spcPts val="0"/>
+              </a:spcBef>
+              <a:spcAft>
+                <a:spcPts val="0"/>
+              </a:spcAft>
+              <a:buClr>
+                <a:srgbClr val="C9C6F5"/>
+              </a:buClr>
+              <a:buSzPts val="1200"/>
+              <a:buFont typeface="Courier New"/>
+              <a:buNone/>
+            </a:pPr>
+            <a:r>
+              <a:rPr b="0" i="0" lang="iw-IL" sz="1200" u="none" cap="none" strike="noStrike">
                 <a:solidFill>
                   <a:srgbClr val="C9C6F5"/>
                 </a:solidFill>
@@ -30251,7 +30288,7 @@
               </a:rPr>
               <a:t>}</a:t>
             </a:r>
-            <a:endParaRPr b="0" i="0" sz="1350" u="none" cap="none" strike="noStrike">
+            <a:endParaRPr b="0" i="0" sz="1200" u="none" cap="none" strike="noStrike">
               <a:solidFill>
                 <a:schemeClr val="dk1"/>
               </a:solidFill>

</xml_diff>

<commit_message>
feat: privacy refusal is a block, move from re-check, out-of-order moves need a reason
- A privacy refusal (OPA or the regex scan) is a block, not a failure: the
  model is skipped, the case goes on with the nurse's acuity and a
  reassessment timer, and the technician is alerted (PRIVACY_REFUSED). Only a
  crash of the payload builder halts the case in agent_failed (AF_PII).
- A patient in reassessment_required can be moved to treatment, under the
  same OPA move rule; they go straight to the treatment pause.
- A move that skips patients still in line needs a reason from a fixed list
  (different_care_area, patient_ahead_unavailable, clinical_judgment),
  enforced in OPA and the shift-lead stand-in, with the skipped positions
  recorded in the audit log.
- Spec, system modeling, status, diagrams and slides 4, 5, 8, 10, 11 updated.
</commit_message>
<xml_diff>
--- a/docs/Triage_Guard_Presentation.pptx
+++ b/docs/Triage_Guard_Presentation.pptx
@@ -5419,7 +5419,7 @@
                 <a:cs typeface="Arial"/>
                 <a:sym typeface="Arial"/>
               </a:rPr>
-              <a:t>500+</a:t>
+              <a:t>1,000+</a:t>
             </a:r>
             <a:endParaRPr b="0" i="0" sz="5000" u="none" cap="none" strike="noStrike">
               <a:solidFill>
@@ -8058,7 +8058,7 @@
                           <a:cs typeface="Arial"/>
                           <a:sym typeface="Arial"/>
                         </a:rPr>
-                        <a:t>רק רשימה מאושרת של שדות מגיעה ל-AI, ו-OPA בודק אותה. פרט מזהה שהוקלד מוחלף בסימון [REDACTED] לפני ה-AI ובכל מה שנשלח ל-Langfuse. המקרה עצמו שומר רק מזהה פנימי, והפרטים המזהים נשמרים רק במערכת הרשומות של בית החולים (CRM).</a:t>
+                        <a:t>רק רשימה מאושרת של שדות מגיעה ל-AI, ו-OPA בודק אותה. אם OPA דוחה אותה, היא לא נשלחת ל-AI: ממשיכים עם הרמה של האחות, והטכנאי מקבל התראה. פרט מזהה שהוקלד מוחלף בסימון [REDACTED] לפני ה-AI ובכל מה שנשלח ל-Langfuse. המקרה עצמו שומר רק מזהה פנימי, והפרטים המזהים נשמרים רק במערכת הרשומות של בית החולים (CRM).</a:t>
                       </a:r>
                       <a:endParaRPr sz="1850" u="none" cap="none" strike="noStrike">
                         <a:latin typeface="Arial"/>
@@ -20381,7 +20381,7 @@
                 <a:cs typeface="Arial"/>
                 <a:sym typeface="Arial"/>
               </a:rPr>
-              <a:t>רכיב קריטי נפל ואין לו חלופה בטוחה (למשל הסרת הפרטים המזהים).</a:t>
+              <a:t>רכיב קריטי נפל ואין לו חלופה בטוחה (למשל קריסה בשלב הסרת הפרטים המזהים).</a:t>
             </a:r>
             <a:endParaRPr b="0" i="0" sz="1800" u="none" cap="none" strike="noStrike">
               <a:solidFill>
@@ -24755,7 +24755,7 @@
                           <a:cs typeface="Arial"/>
                           <a:sym typeface="Arial"/>
                         </a:rPr>
-                        <a:t>עבר בדיקה, אושר, ותפקיד מורשה</a:t>
+                        <a:t>עבר בדיקה, אושר, תפקיד מורשה; דילוג דורש סיבה</a:t>
                       </a:r>
                       <a:endParaRPr sz="1600" u="none" cap="none" strike="noStrike">
                         <a:latin typeface="Arial"/>
@@ -24917,7 +24917,7 @@
                           <a:cs typeface="Courier New"/>
                           <a:sym typeface="Courier New"/>
                         </a:rPr>
-                        <a:t>monitoring</a:t>
+                        <a:t>monitoring / reassessment_required</a:t>
                       </a:r>
                       <a:endParaRPr sz="1300" u="none" cap="none" strike="noStrike">
                         <a:latin typeface="Courier New"/>
@@ -30050,12 +30050,12 @@
               <a:buClr>
                 <a:srgbClr val="C9C6F5"/>
               </a:buClr>
-              <a:buSzPts val="1350"/>
+              <a:buSzPts val="1200"/>
               <a:buFont typeface="Courier New"/>
               <a:buNone/>
             </a:pPr>
             <a:r>
-              <a:rPr b="0" i="0" lang="iw-IL" sz="1350" u="none" cap="none" strike="noStrike">
+              <a:rPr b="0" i="0" lang="iw-IL" sz="1200" u="none" cap="none" strike="noStrike">
                 <a:solidFill>
                   <a:srgbClr val="C9C6F5"/>
                 </a:solidFill>
@@ -30066,7 +30066,7 @@
               </a:rPr>
               <a:t>allow if {</a:t>
             </a:r>
-            <a:endParaRPr b="0" i="0" sz="1350" u="none" cap="none" strike="noStrike">
+            <a:endParaRPr b="0" i="0" sz="1200" u="none" cap="none" strike="noStrike">
               <a:solidFill>
                 <a:schemeClr val="dk1"/>
               </a:solidFill>
@@ -30087,12 +30087,12 @@
               <a:buClr>
                 <a:srgbClr val="C9C6F5"/>
               </a:buClr>
-              <a:buSzPts val="1350"/>
+              <a:buSzPts val="1200"/>
               <a:buFont typeface="Courier New"/>
               <a:buNone/>
             </a:pPr>
             <a:r>
-              <a:rPr b="0" i="0" lang="iw-IL" sz="1350" u="none" cap="none" strike="noStrike">
+              <a:rPr b="0" i="0" lang="iw-IL" sz="1200" u="none" cap="none" strike="noStrike">
                 <a:solidFill>
                   <a:srgbClr val="C9C6F5"/>
                 </a:solidFill>
@@ -30103,7 +30103,7 @@
               </a:rPr>
               <a:t>  input.action == "move"</a:t>
             </a:r>
-            <a:endParaRPr b="0" i="0" sz="1350" u="none" cap="none" strike="noStrike">
+            <a:endParaRPr b="0" i="0" sz="1200" u="none" cap="none" strike="noStrike">
               <a:solidFill>
                 <a:schemeClr val="dk1"/>
               </a:solidFill>
@@ -30124,12 +30124,12 @@
               <a:buClr>
                 <a:srgbClr val="C9C6F5"/>
               </a:buClr>
-              <a:buSzPts val="1350"/>
+              <a:buSzPts val="1200"/>
               <a:buFont typeface="Courier New"/>
               <a:buNone/>
             </a:pPr>
             <a:r>
-              <a:rPr b="0" i="0" lang="iw-IL" sz="1350" u="none" cap="none" strike="noStrike">
+              <a:rPr b="0" i="0" lang="iw-IL" sz="1200" u="none" cap="none" strike="noStrike">
                 <a:solidFill>
                   <a:srgbClr val="C9C6F5"/>
                 </a:solidFill>
@@ -30140,7 +30140,7 @@
               </a:rPr>
               <a:t>  safety_settled</a:t>
             </a:r>
-            <a:endParaRPr b="0" i="0" sz="1350" u="none" cap="none" strike="noStrike">
+            <a:endParaRPr b="0" i="0" sz="1200" u="none" cap="none" strike="noStrike">
               <a:solidFill>
                 <a:schemeClr val="dk1"/>
               </a:solidFill>
@@ -30161,12 +30161,12 @@
               <a:buClr>
                 <a:srgbClr val="C9C6F5"/>
               </a:buClr>
-              <a:buSzPts val="1350"/>
+              <a:buSzPts val="1200"/>
               <a:buFont typeface="Courier New"/>
               <a:buNone/>
             </a:pPr>
             <a:r>
-              <a:rPr b="0" i="0" lang="iw-IL" sz="1350" u="none" cap="none" strike="noStrike">
+              <a:rPr b="0" i="0" lang="iw-IL" sz="1200" u="none" cap="none" strike="noStrike">
                 <a:solidFill>
                   <a:srgbClr val="C9C6F5"/>
                 </a:solidFill>
@@ -30177,7 +30177,7 @@
               </a:rPr>
               <a:t>  input.case.approved == true</a:t>
             </a:r>
-            <a:endParaRPr b="0" i="0" sz="1350" u="none" cap="none" strike="noStrike">
+            <a:endParaRPr b="0" i="0" sz="1200" u="none" cap="none" strike="noStrike">
               <a:solidFill>
                 <a:schemeClr val="dk1"/>
               </a:solidFill>
@@ -30198,12 +30198,12 @@
               <a:buClr>
                 <a:srgbClr val="C9C6F5"/>
               </a:buClr>
-              <a:buSzPts val="1350"/>
+              <a:buSzPts val="1200"/>
               <a:buFont typeface="Courier New"/>
               <a:buNone/>
             </a:pPr>
             <a:r>
-              <a:rPr b="0" i="0" lang="iw-IL" sz="1350" u="none" cap="none" strike="noStrike">
+              <a:rPr b="0" i="0" lang="iw-IL" sz="1200" u="none" cap="none" strike="noStrike">
                 <a:solidFill>
                   <a:srgbClr val="C9C6F5"/>
                 </a:solidFill>
@@ -30214,7 +30214,7 @@
               </a:rPr>
               <a:t>  input.actor_role in move_roles</a:t>
             </a:r>
-            <a:endParaRPr b="0" i="0" sz="1350" u="none" cap="none" strike="noStrike">
+            <a:endParaRPr b="0" i="0" sz="1200" u="none" cap="none" strike="noStrike">
               <a:solidFill>
                 <a:schemeClr val="dk1"/>
               </a:solidFill>
@@ -30235,12 +30235,49 @@
               <a:buClr>
                 <a:srgbClr val="C9C6F5"/>
               </a:buClr>
-              <a:buSzPts val="1350"/>
+              <a:buSzPts val="1200"/>
               <a:buFont typeface="Courier New"/>
               <a:buNone/>
             </a:pPr>
             <a:r>
-              <a:rPr b="0" i="0" lang="iw-IL" sz="1350" u="none" cap="none" strike="noStrike">
+              <a:rPr b="0" i="0" lang="iw-IL" sz="1200" u="none" cap="none" strike="noStrike">
+                <a:solidFill>
+                  <a:srgbClr val="C9C6F5"/>
+                </a:solidFill>
+                <a:latin typeface="Courier New"/>
+                <a:ea typeface="Courier New"/>
+                <a:cs typeface="Courier New"/>
+                <a:sym typeface="Courier New"/>
+              </a:rPr>
+              <a:t>  order_settled</a:t>
+            </a:r>
+            <a:endParaRPr b="0" i="0" sz="1200" u="none" cap="none" strike="noStrike">
+              <a:solidFill>
+                <a:schemeClr val="dk1"/>
+              </a:solidFill>
+              <a:latin typeface="Calibri"/>
+              <a:ea typeface="Calibri"/>
+              <a:cs typeface="Calibri"/>
+              <a:sym typeface="Calibri"/>
+            </a:endParaRPr>
+          </a:p>
+          <a:p>
+            <a:pPr indent="0" lvl="0" marL="0" marR="0" rtl="0" algn="l">
+              <a:spcBef>
+                <a:spcPts val="0"/>
+              </a:spcBef>
+              <a:spcAft>
+                <a:spcPts val="0"/>
+              </a:spcAft>
+              <a:buClr>
+                <a:srgbClr val="C9C6F5"/>
+              </a:buClr>
+              <a:buSzPts val="1200"/>
+              <a:buFont typeface="Courier New"/>
+              <a:buNone/>
+            </a:pPr>
+            <a:r>
+              <a:rPr b="0" i="0" lang="iw-IL" sz="1200" u="none" cap="none" strike="noStrike">
                 <a:solidFill>
                   <a:srgbClr val="C9C6F5"/>
                 </a:solidFill>
@@ -30251,7 +30288,7 @@
               </a:rPr>
               <a:t>}</a:t>
             </a:r>
-            <a:endParaRPr b="0" i="0" sz="1350" u="none" cap="none" strike="noStrike">
+            <a:endParaRPr b="0" i="0" sz="1200" u="none" cap="none" strike="noStrike">
               <a:solidFill>
                 <a:schemeClr val="dk1"/>
               </a:solidFill>

</xml_diff>